<commit_message>
docs(finale): tighter spoken script, about 8 to 8.5 minutes
</commit_message>
<xml_diff>
--- a/finale/Grenuke_Finale_Deck.pptx
+++ b/finale/Grenuke_Finale_Deck.pptx
@@ -3723,7 +3723,7 @@
           <a:lstStyle/>
           <a:p>
             <a:r>
-              <a:t>(15 seconds) Hi, we are team Grenuke: Ameya, Aarush and Sachi. Three students, about 72 hours, one laptop and a few rented GPUs. This is the story of how we turned 24 million business records into a solution that finished second among more than 32,000 teams, and what we learned on the way.</a:t>
+              <a:t>(15 s) Hi, we are team Grenuke: Ameya, Aarush and Sachi. Three students, about 72 hours, one laptop and a few rented GPUs. This is how we turned 24 million records into a solution that finished second among more than 32,000 teams.</a:t>
             </a:r>
           </a:p>
         </p:txBody>
@@ -3781,7 +3781,7 @@
           <a:lstStyle/>
           <a:p>
             <a:r>
-              <a:t>(45 seconds) Here is our architecture in seven steps. Blue is data, navy is our models, and orange is where we decide. We clean the records and retrieve candidates. XGBoost, a fast tree model, scores every pair using name, address, house-number and rival features. The pairs it is unsure about are re-read by transformer models: e5, bge and Qwen. A second XGBoost combines their votes into a calibrated probability. Then we decide per entity. Finally, rules catch known decoys, and a 7B model re-checks the answers we were most sure of.</a:t>
+              <a:t>(30 s) Our architecture has seven steps. Blue is data, navy our models, orange our decisions. We clean records and retrieve candidates. XGBoost scores every pair on name, address, number and rival features. Transformers, e5, bge and Qwen, re-read the unsure pairs. A second XGBoost turns their votes into a calibrated probability. We decide per entity, and finally rules and a 7B model check for decoys.</a:t>
             </a:r>
           </a:p>
         </p:txBody>
@@ -3839,7 +3839,7 @@
           <a:lstStyle/>
           <a:p>
             <a:r>
-              <a:t>(40 seconds) Here is how one decision works. Each candidate gets a calibrated probability. We sort them and keep adding matches while the expected F0.5 for this entity goes up. The two real copies are kept. The look-alike with a similar name, and the bakery at the same address, are dropped. And every record belongs to only one entity, so two entities can never claim the same record. These probabilities are illustrative.</a:t>
+              <a:t>(25 s) Here is one decision. Each candidate gets a probability. We keep adding matches while the expected F0.5 goes up: the two real copies stay; the look-alike name and the bakery at the same address go. And each record has one owner, so two entities can never share it.</a:t>
             </a:r>
           </a:p>
         </p:txBody>
@@ -3897,7 +3897,7 @@
           <a:lstStyle/>
           <a:p>
             <a:r>
-              <a:t>(40 seconds) We kept performance in mind at every step. Each stage shrinks the work for the next: about 34 candidates per entity from retrieval, under 5 after a cheap first filter, 3.7 into the main models. The core pipeline ran on a laptop-sized machine, one 12 gigabyte GPU and 31 gigabytes of memory: blocking in about 13 minutes, with memory peaking at 19 gigabytes. Everything is vectorised; we never loop over pairs in Python. Only the transformers needed rented GPUs, and they read under 3 percent of pairs.</a:t>
+              <a:t>(25 s) We kept performance in mind throughout. Each stage shrinks the next: 34 candidates per entity, under 5 after a cheap filter, 3.7 into the main models. The core pipeline ran on one 12 gigabyte GPU with 31 gigabytes of memory, blocking in about 13 minutes. Only the transformers needed rented GPUs, and they read under 3 percent of pairs.</a:t>
             </a:r>
           </a:p>
         </p:txBody>
@@ -4013,7 +4013,7 @@
           <a:lstStyle/>
           <a:p>
             <a:r>
-              <a:t>(40 seconds) Our first uploads were humbling. Our validation said 0.989; the leaderboard said 0.980. We treated that gap like a bug report. We ruled out bugs in our files, then split the gap by country. The US and India matched our validation, so the whole gap was France, at about 0.93. Then we read the French mistakes by hand, and found the decoys our model was accepting: one word swapped, same address.</a:t>
+              <a:t>(25 s) Our first scores were humbling: 0.989 on our validation, 0.980 on the leaderboard. We treated the gap like a bug report. Splitting it by country showed the US and India were fine; the whole gap was France, at about 0.93. Reading the French errors by hand showed us the decoys we were accepting.</a:t>
             </a:r>
           </a:p>
         </p:txBody>
@@ -4071,7 +4071,7 @@
           <a:lstStyle/>
           <a:p>
             <a:r>
-              <a:t>(45 seconds) France had no labels, so we let the data teach us, carefully. First, we learned which French words signal a look-alike, without labels. Second, the model learned from its own most confident French answers, with checks so no pair ever grades itself. Honestly, this failed twice before it worked. Third, a second opinion: different model families vote, and a 7B model re-checks confident answers. We estimate France rose from about 0.93 to 0.98; it is an estimate, because France was never measured directly.</a:t>
+              <a:t>(30 s) France had no labels, so we let the data teach us. We learned which French words mark a look-alike, without labels. The model learned from its own confident answers, cross-checked so no pair grades itself; honestly, that failed twice before it worked. And different models vote, with a 7B re-check. France rose from about 0.93 to 0.98, an estimate, since it was never measured directly.</a:t>
             </a:r>
           </a:p>
         </p:txBody>
@@ -4187,7 +4187,7 @@
           <a:lstStyle/>
           <a:p>
             <a:r>
-              <a:t>(35 seconds) We were three people, so we tried everything we could. We ran 329 measured experiments, kept 177 and dropped 126, and every upload tested one change. Ameya led the data work, blocking and France. Aarush trained the 7B model and built the final submission. Sachi built our testing gates, a Qwen model and synthetic French data. One rule kept us honest: when two ideas tie, keep the simpler one.</a:t>
+              <a:t>(25 s) As three people, we tried everything: 329 experiments, 177 kept, 126 dropped, each upload testing one change. Ameya led the data, blocking and France; Aarush the 7B model and the final submission; Sachi our testing gates, a Qwen model and synthetic French. Our rule: when two ideas tie, keep the simpler one.</a:t>
             </a:r>
           </a:p>
         </p:txBody>
@@ -4245,7 +4245,7 @@
           <a:lstStyle/>
           <a:p>
             <a:r>
-              <a:t>(35 seconds) This is our climb on the public leaderboard, from 0.976 to 0.991. Each point is one upload, and each one changed one thing we understood. Behind this line are long nights, a laptop that froze at 3:35 in the morning, and a rented GPU we lost mid-run. Our final score was 0.990879, and we finished second of the top ten, among more than 32,000 teams.</a:t>
+              <a:t>(20 s) This is our climb, from 0.976 to 0.991, one understood change per upload. Behind it are long nights, a laptop that froze at 3:35 in the morning, and a GPU lost mid-run. We finished at 0.990879, second of the top ten among more than 32,000 teams.</a:t>
             </a:r>
           </a:p>
         </p:txBody>
@@ -4303,7 +4303,7 @@
           <a:lstStyle/>
           <a:p>
             <a:r>
-              <a:t>(30 seconds) Three lessons. Data first: every good decision we made traced back to reading the data. Doubt your own estimates: ours were built on our own model, so they shared its blind spots, and the leaderboard corrected us. And diversity wins: different models together beat one strong model, most of all in a country you have never seen.</a:t>
+              <a:t>(15 s) Three lessons. Data first: every good decision traced back to it. Doubt your estimates: ours shared our model's blind spots. Diversity wins: different models together beat one strong model, especially in the unknown.</a:t>
             </a:r>
           </a:p>
         </p:txBody>
@@ -4400,7 +4400,7 @@
           <a:lstStyle/>
           <a:p>
             <a:r>
-              <a:t>(35 seconds) We began where every ML project should begin: with the data. There were 24.2 million records from three sources. The training set covers only the US and India. The test set adds France, 15 percent of it, with no labels at all. And the US part of the test is half the size of training, which quietly changes any feature built on counts. We wrote all of this down before building anything.</a:t>
+              <a:t>(25 s) We began where every ML project should: with the data. 24.2 million records from three sources. Training covers only the US and India. The test adds France, 15 percent, with no labels at all. And the US part of the test is half the size, which quietly shifts any count-based feature.</a:t>
             </a:r>
           </a:p>
         </p:txBody>
@@ -4516,7 +4516,7 @@
           <a:lstStyle/>
           <a:p>
             <a:r>
-              <a:t>(40 seconds) How would this scale to billions of records? First, scale out: shard the work by country and region, so a new record only searches its own shard and we never re-run everything. Second, run lighter: distil our transformer ensemble into one small model, quantise it, and cache scores. Third, at the edge: when a business signs up, XGBoost and a small model can check for duplicates instantly on an ordinary CPU, while the 7B model stays in the cloud for batch re-checks. The cost driver is candidates per entity, which is why we kept it at 3.7.</a:t>
+              <a:t>(30 s) At billions of records, we would shard by country and region, so new records only search their own shard. We would distil the transformers into one small, quantised model and cache scores. At sign-up, XGBoost and a small model can check for duplicates instantly on a CPU, with the 7B in the cloud for batch checks. Cost follows candidates per entity, so we keep it at 3.7.</a:t>
             </a:r>
           </a:p>
         </p:txBody>
@@ -4574,7 +4574,7 @@
           <a:lstStyle/>
           <a:p>
             <a:r>
-              <a:t>(40 seconds) With more time, we would label a few hundred pairs in each new country, chosen where our models disagree; use city and state as soft keys; match empty addresses better, since they are most of what we miss; and send unsure pairs to human review. And this matters well beyond a leaderboard: de-duplicating business sign-ups, cleaning seller and supplier records, catching duplicate or fake accounts, and launching new marketplaces, which is exactly the problem France gave us.</a:t>
+              <a:t>(25 s) Next, we would add a few hundred labels per new country, use city and state as soft keys, match empty addresses better, and send unsure pairs to people for review. And this applies widely: business sign-ups, seller and supplier records, fake accounts, and launching new marketplaces, which is exactly our France problem.</a:t>
             </a:r>
           </a:p>
         </p:txBody>
@@ -4632,7 +4632,7 @@
           <a:lstStyle/>
           <a:p>
             <a:r>
-              <a:t>(10 seconds) Thank you for listening. Read the data, decide the way the metric scores, and spend compute where it matters. We are happy to take your questions.</a:t>
+              <a:t>(10 s) Thank you for listening. Read the data, decide like the metric, and spend compute where it matters. We are happy to take your questions.</a:t>
             </a:r>
           </a:p>
         </p:txBody>
@@ -4810,7 +4810,7 @@
           <a:lstStyle/>
           <a:p>
             <a:r>
-              <a:t>(35 seconds) Next, what a match looks like. An entity has about three and a half copies on average, and up to eleven. But 5.6 percent have no copy at all, and for them the right answer is empty, which scores full marks. We also checked ownership: across 7.6 million true pairs, not one record belongs to two entities. That became a rule in our design: one owner per record.</a:t>
+              <a:t>(25 s) An entity has about three and a half copies on average, and up to eleven. But 5.6 percent have none, and for them an empty answer is right and scores full marks. Across 7.6 million true pairs, no record belongs to two entities, so we gave every record one owner.</a:t>
             </a:r>
           </a:p>
         </p:txBody>
@@ -4868,7 +4868,7 @@
           <a:lstStyle/>
           <a:p>
             <a:r>
-              <a:t>(35 seconds) How do true copies differ? They are noisy. About 16 percent have a weak name match, mostly in India, where names are transliterated. About 5 percent have a weak or empty address. But both weak at once happens in less than a tenth of a percent, so the name and the address rescue each other. 83 percent keep the same house number, which makes it strong evidence. And there are almost no postcodes.</a:t>
+              <a:t>(25 s) True copies are noisy: 16 percent have a weak name, mostly transliterated Indian names, and 5 percent a weak or empty address. But both weak at once is under a tenth of a percent, so name and address rescue each other. House numbers agree 83 percent of the time, and there are almost no postcodes.</a:t>
             </a:r>
           </a:p>
         </p:txBody>
@@ -4926,7 +4926,7 @@
           <a:lstStyle/>
           <a:p>
             <a:r>
-              <a:t>(40 seconds) Then we found the decoys. The test set has 23 percent more records per entity, but the same number of true matches, so the extra records are look-alikes, built to trick us. They leave fingerprints. A true copy keeps the house number 85 percent of the time; a look-alike only 12 percent. And look-alikes add a business word, like holdings or group, three times as often. One word swapped at the same address is a real copy only 0.6 percent of the time.</a:t>
+              <a:t>(25 s) Then we found the decoys. The test has 23 percent more records per entity but the same true matches, so the extras are look-alikes. They leave fingerprints: a true copy keeps the house number 85 percent of the time, a look-alike only 12, and look-alikes add a business word three times as often.</a:t>
             </a:r>
           </a:p>
         </p:txBody>
@@ -4984,7 +4984,7 @@
           <a:lstStyle/>
           <a:p>
             <a:r>
-              <a:t>(30 seconds) From all this, we set two rules. First, decide like the metric: one wrong merge costs as much as four missed copies, and merging two different businesses is the mistake that hurts a real customer. So, precision first. Second, spend compute where the model is unsure: a cheap model reads every pair, and only 2.6 percent of pairs reach our expensive models.</a:t>
+              <a:t>(25 s) So we set two rules. Decide like the metric: one wrong merge costs as much as four missed copies, and it hurts a real customer, so precision comes first. And spend compute where the model is unsure: a cheap model reads every pair, and only 2.6 percent reach our expensive models.</a:t>
             </a:r>
           </a:p>
         </p:txBody>
@@ -5100,7 +5100,7 @@
           <a:lstStyle/>
           <a:p>
             <a:r>
-              <a:t>(40 seconds) Comparing every entity with every record would mean about 17 trillion pairs. So first, we search for likely candidates: each country separately, using the words in the name and the address, plus a name-only search when the address is empty. Before searching, we repair spellings. Retrieval keeps 99.1 percent of true matches, and a learned cut leaves just 3.7 candidates per entity while keeping 98.4 percent. We chose this soft matching over hard city or state keys, because many true copies have an empty or landmark-only address.</a:t>
+              <a:t>(30 s) Comparing everything would mean 17 trillion pairs. So we search each country separately, by name and address words, with a name-only search when the address is empty, after repairing spellings. That keeps 99.1 percent of true matches, and a learned cut leaves 3.7 candidates per entity while keeping 98.4. We avoided hard city keys because many true copies have no usable address.</a:t>
             </a:r>
           </a:p>
         </p:txBody>

</xml_diff>